<commit_message>
Redraw YSZ stack: MgO 'crucible' is a solid BN heat-dissipation stub
Per R. Guymon's 2026-07-10 review: the ceramic part under the Ta/YSZ/Ta
sandwich is not a crucible but a solid stub that dissipates heat, made of
boron nitride for best results (sometimes MgO). The schematic now draws it
as a solid block labeled 'BN Heat-Dissipation Stub' (28 mm dimension moved
below the stub so it doesn't read as a division), and the matching
'MgO crucible' wording in the manuscript, supplementary figure caption,
and supplementary BOM is corrected. Fact recorded in AGENTS.md.

Co-authored-by: Ronnie Guymon <244881888+ronnie-guymon@users.noreply.github.com>

Co-Authored-By: Claude Fable 5 <noreply@anthropic.com>
</commit_message>
<xml_diff>
--- a/docs/ysz-stack-schematic.pptx
+++ b/docs/ysz-stack-schematic.pptx
@@ -3812,8 +3812,8 @@
         </p:nvSpPr>
         <p:spPr>
           <a:xfrm>
-            <a:off x="2560320" y="2825496"/>
-            <a:ext cx="914400" cy="987552"/>
+            <a:off x="2615184" y="2935224"/>
+            <a:ext cx="804672" cy="877824"/>
           </a:xfrm>
           <a:prstGeom prst="rect">
             <a:avLst/>
@@ -3850,23 +3850,20 @@
           </a:p>
         </p:txBody>
       </p:sp>
-      <p:sp>
-        <p:nvSpPr>
-          <p:cNvPr id="20" name="Rectangle 19"/>
-          <p:cNvSpPr/>
+      <p:cxnSp>
+        <p:nvCxnSpPr>
+          <p:cNvPr id="20" name="Connector 19"/>
+          <p:cNvCxnSpPr/>
           <p:nvPr/>
-        </p:nvSpPr>
-        <p:spPr>
-          <a:xfrm>
-            <a:off x="2615184" y="2825496"/>
-            <a:ext cx="804672" cy="932688"/>
-          </a:xfrm>
-          <a:prstGeom prst="rect">
+        </p:nvCxnSpPr>
+        <p:spPr>
+          <a:xfrm>
+            <a:off x="2615184" y="4023360"/>
+            <a:ext cx="804672" cy="0"/>
+          </a:xfrm>
+          <a:prstGeom prst="line">
             <a:avLst/>
           </a:prstGeom>
-          <a:solidFill>
-            <a:srgbClr val="FFFFFF"/>
-          </a:solidFill>
           <a:ln w="12700">
             <a:solidFill>
               <a:srgbClr val="000000"/>
@@ -3875,27 +3872,20 @@
           <a:effectLst/>
         </p:spPr>
         <p:style>
-          <a:lnRef idx="1">
+          <a:lnRef idx="2">
             <a:schemeClr val="accent1"/>
           </a:lnRef>
-          <a:fillRef idx="3">
+          <a:fillRef idx="0">
             <a:schemeClr val="accent1"/>
           </a:fillRef>
-          <a:effectRef idx="2">
+          <a:effectRef idx="1">
             <a:schemeClr val="accent1"/>
           </a:effectRef>
           <a:fontRef idx="minor">
-            <a:schemeClr val="lt1"/>
+            <a:schemeClr val="tx1"/>
           </a:fontRef>
         </p:style>
-        <p:txBody>
-          <a:bodyPr rtlCol="0" anchor="ctr"/>
-          <a:lstStyle/>
-          <a:p>
-            <a:pPr algn="ctr"/>
-          </a:p>
-        </p:txBody>
-      </p:sp>
+      </p:cxnSp>
       <p:cxnSp>
         <p:nvCxnSpPr>
           <p:cNvPr id="21" name="Connector 20"/>
@@ -3904,8 +3894,8 @@
         </p:nvCxnSpPr>
         <p:spPr>
           <a:xfrm>
-            <a:off x="2615184" y="3611880"/>
-            <a:ext cx="804672" cy="0"/>
+            <a:off x="2615184" y="3977640"/>
+            <a:ext cx="0" cy="91440"/>
           </a:xfrm>
           <a:prstGeom prst="line">
             <a:avLst/>
@@ -3940,7 +3930,7 @@
         </p:nvCxnSpPr>
         <p:spPr>
           <a:xfrm>
-            <a:off x="2615184" y="3566160"/>
+            <a:off x="3419856" y="3977640"/>
             <a:ext cx="0" cy="91440"/>
           </a:xfrm>
           <a:prstGeom prst="line">
@@ -3968,51 +3958,15 @@
           </a:fontRef>
         </p:style>
       </p:cxnSp>
-      <p:cxnSp>
-        <p:nvCxnSpPr>
-          <p:cNvPr id="23" name="Connector 22"/>
-          <p:cNvCxnSpPr/>
-          <p:nvPr/>
-        </p:nvCxnSpPr>
-        <p:spPr>
-          <a:xfrm>
-            <a:off x="3419856" y="3566160"/>
-            <a:ext cx="0" cy="91440"/>
-          </a:xfrm>
-          <a:prstGeom prst="line">
-            <a:avLst/>
-          </a:prstGeom>
-          <a:ln w="12700">
-            <a:solidFill>
-              <a:srgbClr val="000000"/>
-            </a:solidFill>
-          </a:ln>
-          <a:effectLst/>
-        </p:spPr>
-        <p:style>
-          <a:lnRef idx="2">
-            <a:schemeClr val="accent1"/>
-          </a:lnRef>
-          <a:fillRef idx="0">
-            <a:schemeClr val="accent1"/>
-          </a:fillRef>
-          <a:effectRef idx="1">
-            <a:schemeClr val="accent1"/>
-          </a:effectRef>
-          <a:fontRef idx="minor">
-            <a:schemeClr val="tx1"/>
-          </a:fontRef>
-        </p:style>
-      </p:cxnSp>
-      <p:sp>
-        <p:nvSpPr>
-          <p:cNvPr id="24" name="TextBox 23"/>
+      <p:sp>
+        <p:nvSpPr>
+          <p:cNvPr id="23" name="TextBox 22"/>
           <p:cNvSpPr txBox="1"/>
           <p:nvPr/>
         </p:nvSpPr>
         <p:spPr>
           <a:xfrm>
-            <a:off x="2615184" y="3392424"/>
+            <a:off x="2615184" y="4078224"/>
             <a:ext cx="804672" cy="237744"/>
           </a:xfrm>
           <a:prstGeom prst="rect">
@@ -4036,7 +3990,7 @@
       </p:sp>
       <p:sp>
         <p:nvSpPr>
-          <p:cNvPr id="25" name="Rectangle 24"/>
+          <p:cNvPr id="24" name="Rectangle 23"/>
           <p:cNvSpPr/>
           <p:nvPr/>
         </p:nvSpPr>
@@ -4082,7 +4036,7 @@
       </p:sp>
       <p:sp>
         <p:nvSpPr>
-          <p:cNvPr id="26" name="Rectangle 25"/>
+          <p:cNvPr id="25" name="Rectangle 24"/>
           <p:cNvSpPr/>
           <p:nvPr/>
         </p:nvSpPr>
@@ -4128,7 +4082,7 @@
       </p:sp>
       <p:sp>
         <p:nvSpPr>
-          <p:cNvPr id="27" name="Rectangle 26"/>
+          <p:cNvPr id="26" name="Rectangle 25"/>
           <p:cNvSpPr/>
           <p:nvPr/>
         </p:nvSpPr>
@@ -4174,14 +4128,50 @@
       </p:sp>
       <p:cxnSp>
         <p:nvCxnSpPr>
+          <p:cNvPr id="27" name="Connector 26"/>
+          <p:cNvCxnSpPr/>
+          <p:nvPr/>
+        </p:nvCxnSpPr>
+        <p:spPr>
+          <a:xfrm>
+            <a:off x="2651760" y="1481328"/>
+            <a:ext cx="731520" cy="0"/>
+          </a:xfrm>
+          <a:prstGeom prst="line">
+            <a:avLst/>
+          </a:prstGeom>
+          <a:ln w="12700">
+            <a:solidFill>
+              <a:srgbClr val="000000"/>
+            </a:solidFill>
+          </a:ln>
+          <a:effectLst/>
+        </p:spPr>
+        <p:style>
+          <a:lnRef idx="2">
+            <a:schemeClr val="accent1"/>
+          </a:lnRef>
+          <a:fillRef idx="0">
+            <a:schemeClr val="accent1"/>
+          </a:fillRef>
+          <a:effectRef idx="1">
+            <a:schemeClr val="accent1"/>
+          </a:effectRef>
+          <a:fontRef idx="minor">
+            <a:schemeClr val="tx1"/>
+          </a:fontRef>
+        </p:style>
+      </p:cxnSp>
+      <p:cxnSp>
+        <p:nvCxnSpPr>
           <p:cNvPr id="28" name="Connector 27"/>
           <p:cNvCxnSpPr/>
           <p:nvPr/>
         </p:nvCxnSpPr>
         <p:spPr>
           <a:xfrm>
-            <a:off x="2651760" y="1481328"/>
-            <a:ext cx="731520" cy="0"/>
+            <a:off x="2651760" y="1435608"/>
+            <a:ext cx="0" cy="91440"/>
           </a:xfrm>
           <a:prstGeom prst="line">
             <a:avLst/>
@@ -4216,7 +4206,7 @@
         </p:nvCxnSpPr>
         <p:spPr>
           <a:xfrm>
-            <a:off x="2651760" y="1435608"/>
+            <a:off x="3383280" y="1435608"/>
             <a:ext cx="0" cy="91440"/>
           </a:xfrm>
           <a:prstGeom prst="line">
@@ -4244,45 +4234,9 @@
           </a:fontRef>
         </p:style>
       </p:cxnSp>
-      <p:cxnSp>
-        <p:nvCxnSpPr>
-          <p:cNvPr id="30" name="Connector 29"/>
-          <p:cNvCxnSpPr/>
-          <p:nvPr/>
-        </p:nvCxnSpPr>
-        <p:spPr>
-          <a:xfrm>
-            <a:off x="3383280" y="1435608"/>
-            <a:ext cx="0" cy="91440"/>
-          </a:xfrm>
-          <a:prstGeom prst="line">
-            <a:avLst/>
-          </a:prstGeom>
-          <a:ln w="12700">
-            <a:solidFill>
-              <a:srgbClr val="000000"/>
-            </a:solidFill>
-          </a:ln>
-          <a:effectLst/>
-        </p:spPr>
-        <p:style>
-          <a:lnRef idx="2">
-            <a:schemeClr val="accent1"/>
-          </a:lnRef>
-          <a:fillRef idx="0">
-            <a:schemeClr val="accent1"/>
-          </a:fillRef>
-          <a:effectRef idx="1">
-            <a:schemeClr val="accent1"/>
-          </a:effectRef>
-          <a:fontRef idx="minor">
-            <a:schemeClr val="tx1"/>
-          </a:fontRef>
-        </p:style>
-      </p:cxnSp>
-      <p:sp>
-        <p:nvSpPr>
-          <p:cNvPr id="31" name="TextBox 30"/>
+      <p:sp>
+        <p:nvSpPr>
+          <p:cNvPr id="30" name="TextBox 29"/>
           <p:cNvSpPr txBox="1"/>
           <p:nvPr/>
         </p:nvSpPr>
@@ -4312,7 +4266,7 @@
       </p:sp>
       <p:sp>
         <p:nvSpPr>
-          <p:cNvPr id="32" name="TextBox 31"/>
+          <p:cNvPr id="31" name="TextBox 30"/>
           <p:cNvSpPr txBox="1"/>
           <p:nvPr/>
         </p:nvSpPr>
@@ -4342,7 +4296,7 @@
       </p:sp>
       <p:sp>
         <p:nvSpPr>
-          <p:cNvPr id="33" name="TextBox 32"/>
+          <p:cNvPr id="32" name="TextBox 31"/>
           <p:cNvSpPr txBox="1"/>
           <p:nvPr/>
         </p:nvSpPr>
@@ -4372,7 +4326,7 @@
       </p:sp>
       <p:sp>
         <p:nvSpPr>
-          <p:cNvPr id="34" name="TextBox 33"/>
+          <p:cNvPr id="33" name="TextBox 32"/>
           <p:cNvSpPr txBox="1"/>
           <p:nvPr/>
         </p:nvSpPr>
@@ -4402,7 +4356,7 @@
       </p:sp>
       <p:cxnSp>
         <p:nvCxnSpPr>
-          <p:cNvPr id="35" name="Connector 34"/>
+          <p:cNvPr id="34" name="Connector 33"/>
           <p:cNvCxnSpPr/>
           <p:nvPr/>
         </p:nvCxnSpPr>
@@ -4439,7 +4393,7 @@
       </p:cxnSp>
       <p:sp>
         <p:nvSpPr>
-          <p:cNvPr id="36" name="TextBox 35"/>
+          <p:cNvPr id="35" name="TextBox 34"/>
           <p:cNvSpPr txBox="1"/>
           <p:nvPr/>
         </p:nvSpPr>
@@ -4469,7 +4423,7 @@
       </p:sp>
       <p:cxnSp>
         <p:nvCxnSpPr>
-          <p:cNvPr id="37" name="Connector 36"/>
+          <p:cNvPr id="36" name="Connector 35"/>
           <p:cNvCxnSpPr/>
           <p:nvPr/>
         </p:nvCxnSpPr>
@@ -4506,7 +4460,7 @@
       </p:cxnSp>
       <p:sp>
         <p:nvSpPr>
-          <p:cNvPr id="38" name="TextBox 37"/>
+          <p:cNvPr id="37" name="TextBox 36"/>
           <p:cNvSpPr txBox="1"/>
           <p:nvPr/>
         </p:nvSpPr>
@@ -4536,7 +4490,7 @@
       </p:sp>
       <p:cxnSp>
         <p:nvCxnSpPr>
-          <p:cNvPr id="39" name="Connector 38"/>
+          <p:cNvPr id="38" name="Connector 37"/>
           <p:cNvCxnSpPr/>
           <p:nvPr/>
         </p:nvCxnSpPr>
@@ -4573,14 +4527,14 @@
       </p:cxnSp>
       <p:sp>
         <p:nvSpPr>
-          <p:cNvPr id="40" name="TextBox 39"/>
+          <p:cNvPr id="39" name="TextBox 38"/>
           <p:cNvSpPr txBox="1"/>
           <p:nvPr/>
         </p:nvSpPr>
         <p:spPr>
           <a:xfrm>
             <a:off x="4315968" y="3182112"/>
-            <a:ext cx="1097280" cy="237744"/>
+            <a:ext cx="1828800" cy="237744"/>
           </a:xfrm>
           <a:prstGeom prst="rect">
             <a:avLst/>
@@ -4596,21 +4550,21 @@
             <a:pPr algn="l"/>
             <a:r>
               <a:rPr sz="1000"/>
-              <a:t>MgO Crucible</a:t>
+              <a:t>BN Heat-Dissipation Stub</a:t>
             </a:r>
           </a:p>
         </p:txBody>
       </p:sp>
       <p:cxnSp>
         <p:nvCxnSpPr>
-          <p:cNvPr id="41" name="Connector 40"/>
+          <p:cNvPr id="40" name="Connector 39"/>
           <p:cNvCxnSpPr/>
           <p:nvPr/>
         </p:nvCxnSpPr>
         <p:spPr>
           <a:xfrm flipH="1">
-            <a:off x="3511296" y="3291840"/>
-            <a:ext cx="768096" cy="0"/>
+            <a:off x="3456432" y="3291840"/>
+            <a:ext cx="822960" cy="0"/>
           </a:xfrm>
           <a:prstGeom prst="line">
             <a:avLst/>
@@ -4640,7 +4594,7 @@
       </p:cxnSp>
       <p:sp>
         <p:nvSpPr>
-          <p:cNvPr id="42" name="TextBox 41"/>
+          <p:cNvPr id="41" name="TextBox 40"/>
           <p:cNvSpPr txBox="1"/>
           <p:nvPr/>
         </p:nvSpPr>
@@ -4670,7 +4624,7 @@
       </p:sp>
       <p:cxnSp>
         <p:nvCxnSpPr>
-          <p:cNvPr id="43" name="Connector 42"/>
+          <p:cNvPr id="42" name="Connector 41"/>
           <p:cNvCxnSpPr/>
           <p:nvPr/>
         </p:nvCxnSpPr>
@@ -4707,7 +4661,7 @@
       </p:cxnSp>
       <p:sp>
         <p:nvSpPr>
-          <p:cNvPr id="44" name="TextBox 43"/>
+          <p:cNvPr id="43" name="TextBox 42"/>
           <p:cNvSpPr txBox="1"/>
           <p:nvPr/>
         </p:nvSpPr>
@@ -4737,7 +4691,7 @@
       </p:sp>
       <p:cxnSp>
         <p:nvCxnSpPr>
-          <p:cNvPr id="45" name="Connector 44"/>
+          <p:cNvPr id="44" name="Connector 43"/>
           <p:cNvCxnSpPr/>
           <p:nvPr/>
         </p:nvCxnSpPr>
@@ -4774,7 +4728,7 @@
       </p:cxnSp>
       <p:sp>
         <p:nvSpPr>
-          <p:cNvPr id="46" name="TextBox 45"/>
+          <p:cNvPr id="45" name="TextBox 44"/>
           <p:cNvSpPr txBox="1"/>
           <p:nvPr/>
         </p:nvSpPr>
@@ -4804,7 +4758,7 @@
       </p:sp>
       <p:cxnSp>
         <p:nvCxnSpPr>
-          <p:cNvPr id="47" name="Connector 46"/>
+          <p:cNvPr id="46" name="Connector 45"/>
           <p:cNvCxnSpPr/>
           <p:nvPr/>
         </p:nvCxnSpPr>

</xml_diff>

<commit_message>
Replace Fig. 1(b) with callout photo; Fig. 8: alumina tube rests on teflon tube
- Fig. 1(b) now uses the labeled "Assembled furnace with callouts" image
  supplied by R. Guymon (source PDF archived in
  docs/assembled-furnace-with-callouts.pdf, rendered at 300 dpi and
  autocropped to paper/figures/fig_furnace_photo_callouts.png).
- Fig. 8 schematic corrected: the teflon tube is underneath the alumina
  support tube, which rests on top of it rather than seating inside it.
  Regenerated docs/ysz-stack-schematic.pptx and fig_ysz_stack.png, and
  updated the Fig. 8 caption and the crucible-section support-path text.
- Rebuilt real_person_paper.pdf (8 pages, no errors).

Co-authored-by: Ronnie Guymon <244881888+ronnie-guymon@users.noreply.github.com>

Co-Authored-By: Claude Fable 5 <noreply@anthropic.com>
</commit_message>
<xml_diff>
--- a/docs/ysz-stack-schematic.pptx
+++ b/docs/ysz-stack-schematic.pptx
@@ -3235,7 +3235,7 @@
         <p:spPr>
           <a:xfrm>
             <a:off x="2788920" y="3813048"/>
-            <a:ext cx="457200" cy="3090672"/>
+            <a:ext cx="457200" cy="2724912"/>
           </a:xfrm>
           <a:prstGeom prst="rect">
             <a:avLst/>
@@ -3281,7 +3281,7 @@
         <p:spPr>
           <a:xfrm>
             <a:off x="2916936" y="3858768"/>
-            <a:ext cx="0" cy="2999232"/>
+            <a:ext cx="0" cy="2633472"/>
           </a:xfrm>
           <a:prstGeom prst="line">
             <a:avLst/>
@@ -3318,7 +3318,7 @@
         <p:spPr>
           <a:xfrm>
             <a:off x="3118104" y="3858768"/>
-            <a:ext cx="0" cy="2999232"/>
+            <a:ext cx="0" cy="2633472"/>
           </a:xfrm>
           <a:prstGeom prst="line">
             <a:avLst/>
@@ -5215,8 +5215,8 @@
         </p:nvCxnSpPr>
         <p:spPr>
           <a:xfrm flipH="1">
-            <a:off x="3355848" y="6464808"/>
-            <a:ext cx="923544" cy="164592"/>
+            <a:off x="3310128" y="6464808"/>
+            <a:ext cx="969264" cy="192024"/>
           </a:xfrm>
           <a:prstGeom prst="line">
             <a:avLst/>

</xml_diff>